<commit_message>
Updated the name of Sai Nimbalkar in PPT and report
</commit_message>
<xml_diff>
--- a/presentation/Disease-Risk-Prediction-Using-Statistical-Modelling.pptx_20260922_193957_0000.pptx
+++ b/presentation/Disease-Risk-Prediction-Using-Statistical-Modelling.pptx_20260922_193957_0000.pptx
@@ -231,7 +231,7 @@
           <a:p>
             <a:fld id="{B7268E1E-0E44-426D-905E-8AD9B19D2182}" type="datetimeFigureOut">
               <a:rPr lang="cs-CZ" smtClean="0"/>
-              <a:t>23.09.2026</a:t>
+              <a:t>24.09.2026</a:t>
             </a:fld>
             <a:endParaRPr lang="cs-CZ"/>
           </a:p>
@@ -2859,7 +2859,7 @@
             <a:fld id="{1D8BD707-D9CF-40AE-B4C6-C98DA3205C09}" type="datetimeFigureOut">
               <a:rPr lang="en-US" smtClean="0"/>
               <a:pPr/>
-              <a:t>9/23/2026</a:t>
+              <a:t>9/24/2026</a:t>
             </a:fld>
             <a:endParaRPr lang="en-US"/>
           </a:p>
@@ -3024,7 +3024,7 @@
             <a:fld id="{1D8BD707-D9CF-40AE-B4C6-C98DA3205C09}" type="datetimeFigureOut">
               <a:rPr lang="en-US" smtClean="0"/>
               <a:pPr/>
-              <a:t>9/23/2026</a:t>
+              <a:t>9/24/2026</a:t>
             </a:fld>
             <a:endParaRPr lang="en-US"/>
           </a:p>
@@ -3199,7 +3199,7 @@
             <a:fld id="{1D8BD707-D9CF-40AE-B4C6-C98DA3205C09}" type="datetimeFigureOut">
               <a:rPr lang="en-US" smtClean="0"/>
               <a:pPr/>
-              <a:t>9/23/2026</a:t>
+              <a:t>9/24/2026</a:t>
             </a:fld>
             <a:endParaRPr lang="en-US"/>
           </a:p>
@@ -3364,7 +3364,7 @@
             <a:fld id="{1D8BD707-D9CF-40AE-B4C6-C98DA3205C09}" type="datetimeFigureOut">
               <a:rPr lang="en-US" smtClean="0"/>
               <a:pPr/>
-              <a:t>9/23/2026</a:t>
+              <a:t>9/24/2026</a:t>
             </a:fld>
             <a:endParaRPr lang="en-US"/>
           </a:p>
@@ -3606,7 +3606,7 @@
             <a:fld id="{1D8BD707-D9CF-40AE-B4C6-C98DA3205C09}" type="datetimeFigureOut">
               <a:rPr lang="en-US" smtClean="0"/>
               <a:pPr/>
-              <a:t>9/23/2026</a:t>
+              <a:t>9/24/2026</a:t>
             </a:fld>
             <a:endParaRPr lang="en-US"/>
           </a:p>
@@ -3888,7 +3888,7 @@
             <a:fld id="{1D8BD707-D9CF-40AE-B4C6-C98DA3205C09}" type="datetimeFigureOut">
               <a:rPr lang="en-US" smtClean="0"/>
               <a:pPr/>
-              <a:t>9/23/2026</a:t>
+              <a:t>9/24/2026</a:t>
             </a:fld>
             <a:endParaRPr lang="en-US"/>
           </a:p>
@@ -4304,7 +4304,7 @@
             <a:fld id="{1D8BD707-D9CF-40AE-B4C6-C98DA3205C09}" type="datetimeFigureOut">
               <a:rPr lang="en-US" smtClean="0"/>
               <a:pPr/>
-              <a:t>9/23/2026</a:t>
+              <a:t>9/24/2026</a:t>
             </a:fld>
             <a:endParaRPr lang="en-US"/>
           </a:p>
@@ -4418,7 +4418,7 @@
             <a:fld id="{1D8BD707-D9CF-40AE-B4C6-C98DA3205C09}" type="datetimeFigureOut">
               <a:rPr lang="en-US" smtClean="0"/>
               <a:pPr/>
-              <a:t>9/23/2026</a:t>
+              <a:t>9/24/2026</a:t>
             </a:fld>
             <a:endParaRPr lang="en-US"/>
           </a:p>
@@ -4510,7 +4510,7 @@
             <a:fld id="{1D8BD707-D9CF-40AE-B4C6-C98DA3205C09}" type="datetimeFigureOut">
               <a:rPr lang="en-US" smtClean="0"/>
               <a:pPr/>
-              <a:t>9/23/2026</a:t>
+              <a:t>9/24/2026</a:t>
             </a:fld>
             <a:endParaRPr lang="en-US"/>
           </a:p>
@@ -4782,7 +4782,7 @@
             <a:fld id="{1D8BD707-D9CF-40AE-B4C6-C98DA3205C09}" type="datetimeFigureOut">
               <a:rPr lang="en-US" smtClean="0"/>
               <a:pPr/>
-              <a:t>9/23/2026</a:t>
+              <a:t>9/24/2026</a:t>
             </a:fld>
             <a:endParaRPr lang="en-US"/>
           </a:p>
@@ -5031,7 +5031,7 @@
             <a:fld id="{1D8BD707-D9CF-40AE-B4C6-C98DA3205C09}" type="datetimeFigureOut">
               <a:rPr lang="en-US" smtClean="0"/>
               <a:pPr/>
-              <a:t>9/23/2026</a:t>
+              <a:t>9/24/2026</a:t>
             </a:fld>
             <a:endParaRPr lang="en-US"/>
           </a:p>
@@ -5239,7 +5239,7 @@
             <a:fld id="{1D8BD707-D9CF-40AE-B4C6-C98DA3205C09}" type="datetimeFigureOut">
               <a:rPr lang="en-US" smtClean="0"/>
               <a:pPr/>
-              <a:t>9/23/2026</a:t>
+              <a:t>9/24/2026</a:t>
             </a:fld>
             <a:endParaRPr lang="en-US"/>
           </a:p>
@@ -5924,7 +5924,7 @@
         <p:spPr>
           <a:xfrm>
             <a:off x="914381" y="8247012"/>
-            <a:ext cx="9143771" cy="1125588"/>
+            <a:ext cx="9143771" cy="541430"/>
           </a:xfrm>
           <a:prstGeom prst="rect">
             <a:avLst/>
@@ -5953,70 +5953,6 @@
               </a:rPr>
               <a:t>Agnel Polytechnic · Department of Artificial Intelligence &amp; Machine Learning · Academic Year 2026–27</a:t>
             </a:r>
-          </a:p>
-          <a:p>
-            <a:pPr algn="l">
-              <a:lnSpc>
-                <a:spcPts val="2211"/>
-              </a:lnSpc>
-            </a:pPr>
-            <a:r>
-              <a:rPr lang="en-US" sz="1575" spc="15" dirty="0">
-                <a:solidFill>
-                  <a:srgbClr val="899198"/>
-                </a:solidFill>
-                <a:latin typeface="JetBrains Mono"/>
-                <a:ea typeface="JetBrains Mono"/>
-                <a:cs typeface="JetBrains Mono"/>
-                <a:sym typeface="JetBrains Mono"/>
-              </a:rPr>
-              <a:t>Nirbhay More · Gaus Mulla · Gitesh </a:t>
-            </a:r>
-            <a:r>
-              <a:rPr lang="en-US" sz="1575" spc="15" dirty="0" err="1">
-                <a:solidFill>
-                  <a:srgbClr val="899198"/>
-                </a:solidFill>
-                <a:latin typeface="JetBrains Mono"/>
-                <a:ea typeface="JetBrains Mono"/>
-                <a:cs typeface="JetBrains Mono"/>
-                <a:sym typeface="JetBrains Mono"/>
-              </a:rPr>
-              <a:t>Netkar</a:t>
-            </a:r>
-            <a:r>
-              <a:rPr lang="en-US" sz="1575" spc="15" dirty="0">
-                <a:solidFill>
-                  <a:srgbClr val="899198"/>
-                </a:solidFill>
-                <a:latin typeface="JetBrains Mono"/>
-                <a:ea typeface="JetBrains Mono"/>
-                <a:cs typeface="JetBrains Mono"/>
-                <a:sym typeface="JetBrains Mono"/>
-              </a:rPr>
-              <a:t> · Sai </a:t>
-            </a:r>
-            <a:r>
-              <a:rPr lang="en-US" sz="1575" spc="15" dirty="0" err="1">
-                <a:solidFill>
-                  <a:srgbClr val="899198"/>
-                </a:solidFill>
-                <a:latin typeface="JetBrains Mono"/>
-                <a:ea typeface="JetBrains Mono"/>
-                <a:cs typeface="JetBrains Mono"/>
-                <a:sym typeface="JetBrains Mono"/>
-              </a:rPr>
-              <a:t>Nimbulkar</a:t>
-            </a:r>
-            <a:endParaRPr lang="en-US" sz="1575" spc="15" dirty="0">
-              <a:solidFill>
-                <a:srgbClr val="899198"/>
-              </a:solidFill>
-              <a:latin typeface="JetBrains Mono"/>
-              <a:ea typeface="JetBrains Mono"/>
-              <a:cs typeface="JetBrains Mono"/>
-              <a:sym typeface="JetBrains Mono"/>
-            </a:endParaRPr>
           </a:p>
         </p:txBody>
       </p:sp>
@@ -6192,31 +6128,7 @@
                 <a:cs typeface="JetBrains Mono"/>
                 <a:sym typeface="JetBrains Mono"/>
               </a:rPr>
-              <a:t>·Sai </a:t>
-            </a:r>
-            <a:r>
-              <a:rPr lang="en-US" sz="3200" spc="15" dirty="0" err="1">
-                <a:solidFill>
-                  <a:srgbClr val="899198"/>
-                </a:solidFill>
-                <a:latin typeface="JetBrains Mono"/>
-                <a:ea typeface="JetBrains Mono"/>
-                <a:cs typeface="JetBrains Mono"/>
-                <a:sym typeface="JetBrains Mono"/>
-              </a:rPr>
-              <a:t>Nimbulkar</a:t>
-            </a:r>
-            <a:r>
-              <a:rPr lang="en-US" sz="3200" spc="15" dirty="0">
-                <a:solidFill>
-                  <a:srgbClr val="899198"/>
-                </a:solidFill>
-                <a:latin typeface="JetBrains Mono"/>
-                <a:ea typeface="JetBrains Mono"/>
-                <a:cs typeface="JetBrains Mono"/>
-                <a:sym typeface="JetBrains Mono"/>
-              </a:rPr>
-              <a:t> (25939)</a:t>
+              <a:t>·Sai Nimbalkar (25939)</a:t>
             </a:r>
           </a:p>
         </p:txBody>
@@ -6747,31 +6659,7 @@
                 <a:cs typeface="JetBrains Mono"/>
                 <a:sym typeface="JetBrains Mono"/>
               </a:rPr>
-              <a:t>Sai </a:t>
-            </a:r>
-            <a:r>
-              <a:rPr lang="en-US" sz="2250" dirty="0" err="1">
-                <a:solidFill>
-                  <a:srgbClr val="F2F0E8"/>
-                </a:solidFill>
-                <a:latin typeface="JetBrains Mono"/>
-                <a:ea typeface="JetBrains Mono"/>
-                <a:cs typeface="JetBrains Mono"/>
-                <a:sym typeface="JetBrains Mono"/>
-              </a:rPr>
-              <a:t>Nimbulkar</a:t>
-            </a:r>
-            <a:r>
-              <a:rPr lang="en-US" sz="2250" dirty="0">
-                <a:solidFill>
-                  <a:srgbClr val="F2F0E8"/>
-                </a:solidFill>
-                <a:latin typeface="JetBrains Mono"/>
-                <a:ea typeface="JetBrains Mono"/>
-                <a:cs typeface="JetBrains Mono"/>
-                <a:sym typeface="JetBrains Mono"/>
-              </a:rPr>
-              <a:t> (25939)</a:t>
+              <a:t>Sai Nimbalkar (25939)</a:t>
             </a:r>
           </a:p>
         </p:txBody>

</xml_diff>